<commit_message>
docs: add speaker notes to final presentation
</commit_message>
<xml_diff>
--- a/final_presentation/PROJECT_CONCLUSION_DECK_2026-07-22.pptx
+++ b/final_presentation/PROJECT_CONCLUSION_DECK_2026-07-22.pptx
@@ -521,7 +521,8 @@
           <a:p>
             <a:r>
               <a:rPr lang="en-US" dirty="0"/>
-              <a:t/>
+              <a:t>大家好，我们汇报的题目是《从遥感基础表征读取到异构先验注入》。这项工作研究 Galileo 遥感基础模型在 PASTIS 作物时序分割任务上的迁移。我们把 Galileo 的 encoder 冻结下来，先研究它学到的空间和时间信息怎样被下游网络读出来，再进一步看物候、气候、土壤和地理知识能不能提供视觉信息之外的补充。
+这次汇报不按模型清单来讲，而是按照研究问题怎样一步步形成来讲。我们先从任务背景和意义开始，再进入空间读取、时间融合和异构先验注入。首先看为什么作物识别需要一整年的观测。</a:t>
             </a:r>
             <a:endParaRPr lang="en-US" dirty="0"/>
           </a:p>
@@ -609,7 +610,8 @@
           <a:p>
             <a:r>
               <a:rPr lang="en-US" dirty="0"/>
-              <a:t/>
+              <a:t>总体 mIoU 接近 0.60，并不代表每一个类别都已经解决。玉米、油菜和甜菜的结果已经比较高，说明明显的季节变化可以被时间融合捕捉；冬小黑麦、豆科饲料和高粱仍然偏低，果园和混合谷物这类多年生或聚合类别也比较困难。
+不同类别需要的线索并不一样，有些类别甚至没有一条标准物候曲线可以直接套用。因此后面不再把先验理解成再加一张表就应该涨分，而是研究什么知识适合什么视觉内容、模型能不能自主选择，以及选择过程能不能被诊断。下一页先从最简单的 V1 反事实验证开始。</a:t>
             </a:r>
             <a:endParaRPr lang="en-US" dirty="0"/>
           </a:p>
@@ -697,7 +699,8 @@
           <a:p>
             <a:r>
               <a:rPr lang="en-US" dirty="0"/>
-              <a:t/>
+              <a:t>V1 先做一个最小实验：把类别—月份物候表经过小编码器变成先验残差，再广播到所有空间位置。它的目的不是提出最终方法，而是判断正确物候内容是否比没有物候或类别置乱更有用。
+需要强调，P0、P1、P2 都属于 Single Temporal Readout 这一组。P0 无先验的 mIoU 是 0.54938，正确物候 P1 是 0.55316，提高 0.378 个百分点；类别对应关系置乱后，P2 降到 0.54784。结果说明物候可能有弱信号，但提升很小，而且全局广播太粗，同一份先验被无差别地送到所有位置。因此 V1 适合做方向验证，不适合作为最终通用方案。</a:t>
             </a:r>
             <a:endParaRPr lang="en-US" dirty="0"/>
           </a:p>
@@ -785,7 +788,8 @@
           <a:p>
             <a:r>
               <a:rPr lang="en-US" dirty="0"/>
-              <a:t/>
+              <a:t>V1 的问题不仅在于物候表，也在于它默认所有先验都能用相同方式广播。因此我们先把不同先验整理成统一的 PriorBatch。M1 是类别和月份物候，M2 是月度气候背景，M3 是多深度土壤属性，M4 是标准化地理上下文。
+统一接口并不意味着抹平来源差异。PriorBatch 同时保留 tokens、mask、confidence 和 source id，让后续模型能够判断当前视觉内容应该参考哪个来源、哪些 token 有效。这里也明确数据边界：M2、M3、M4 是外部背景或模型化资料，不表述为地块实测数据，也不使用 test 标签挑选先验。</a:t>
             </a:r>
             <a:endParaRPr lang="en-US" dirty="0"/>
           </a:p>
@@ -873,7 +877,8 @@
           <a:p>
             <a:r>
               <a:rPr lang="en-US" dirty="0"/>
-              <a:t/>
+              <a:t>CA-HPI 的核心变化，是把先验从广播信号变成可查询的知识库。以一个视觉 token 为例，它经过投影得到 Query；PriorBatch 中的先验 token 经过 Key 和 Value 投影。每一个空间位置、月份和网络层都可以根据当前视觉内容，得到不同的先验上下文。
+mask 和 confidence 会一起参与查询，无效先验不进入注意力，低置信度信息也不会与可靠信息完全等价。候选残差再经过 content gate 和逐层 strength 控制，写回 decoder 前特征，输出形状不变。它与 V1 的区别并不是简单多一个 attention，而是把是否需要这份知识的选择权交给当前视觉内容。</a:t>
             </a:r>
             <a:endParaRPr lang="en-US" dirty="0"/>
           </a:p>
@@ -961,7 +966,8 @@
           <a:p>
             <a:r>
               <a:rPr lang="en-US" dirty="0"/>
-              <a:t/>
+              <a:t>结果首先支持了 CA-HPI 的基本方向。只使用 M1 时，E7 的 Test mIoU 是 0.60443，比无先验 B0 高 0.498 个百分点；加入 M2 和 M3 后，E8 仍略高于 B0，但降到 0.60192；四个来源全部放入后，E9 反而降到 0.59395。
+逐类结果更能说明问题。Grapevine 在 M1-only 下明显提高，Orchard 在四源组合下得到补充，但 Sorghum 从 M1-only 的正向变化变成四源组合的大幅下降。总体 mIoU 是各类别正负变化抵消后的结果，不能简单归纳为加来源有效或无效。它给 V3 提出了具体要求：先在来源内部选择，再比较来源之间的权重，并控制先验改动哪些通道和空间位置。</a:t>
             </a:r>
             <a:endParaRPr lang="en-US" dirty="0"/>
           </a:p>
@@ -1049,7 +1055,8 @@
           <a:p>
             <a:r>
               <a:rPr lang="en-US" dirty="0"/>
-              <a:t/>
+              <a:t>下面三页不逐行念完 19 个类别，而是用逐类结果确认先验的收益边界。先看背景和主要季节作物。相对 B0，E10 在 Meadow 上提高约 1.7 个百分点，在 Soft winter wheat 上提高约 1.6 个百分点，在 Winter barley 上提高约 2.5 个百分点。
+但并不是所有季节作物都同步提升。Corn 基本持平，Winter rapeseed 下降约 1.2 个百分点，Spring barley 也略有下降。因此即使一类作物具有明显季节性，先验是否有用仍取决于视觉模型已经学到了多少，以及注入架构如何调制这些信息。</a:t>
             </a:r>
             <a:endParaRPr lang="en-US" dirty="0"/>
           </a:p>
@@ -1137,7 +1144,8 @@
           <a:p>
             <a:r>
               <a:rPr lang="en-US" dirty="0"/>
-              <a:t/>
+              <a:t>第二组类别里，Grapevine 是比较清楚的正向例子。E10 相对 B0 提高约 4.0 个百分点，说明先验确实可能补充视觉信息；Beet 提高约 1.1 个百分点，Winter durum wheat 提高约 2.7 个百分点。
+同时也能看到来源组合和类别差异。Grapevine 在 E7 的 M1-only 配置下提升更明显，加入多源后收益并没有继续增加。Winter triticale 和 Fruits, vegetables, flowers 仍然下降。因此逐类结果用于解释边界，不能把某一个类别的变化单独当成普遍结论。</a:t>
             </a:r>
             <a:endParaRPr lang="en-US" dirty="0"/>
           </a:p>
@@ -1225,7 +1233,8 @@
           <a:p>
             <a:r>
               <a:rPr lang="en-US" dirty="0"/>
-              <a:t/>
+              <a:t>最后一组更集中地展示困难类别。Orchard 相对 B0 提高约 3.4 个百分点，Potatoes 略有提升，说明环境或地理上下文可能对部分类别提供补充。
+但 Leguminous fodder、Soybeans、Mixed cereal 和 Sorghum 都出现下降，其中混合谷物和高粱下降约 3 个百分点。也就是说，最困难和最混合的类别并没有因为加入更多先验而自动解决。这三页共同支持的结论不是先验一定有效，而是先验作用具有类别选择性，并且受到来源组合与融合架构的约束。</a:t>
             </a:r>
             <a:endParaRPr lang="en-US" dirty="0"/>
           </a:p>
@@ -1313,7 +1322,8 @@
           <a:p>
             <a:r>
               <a:rPr lang="en-US" dirty="0"/>
-              <a:t/>
+              <a:t>V3 不是简单在 CA-HPI 后面再加一个 FiLM，而是把先验选择拆成几个层次。首先，每个来源内部单独做 attention，得到四份 context，避免 token 数量多的来源在一次全局 softmax 中天然占优势。然后 Source Gate 根据当前视觉内容比较四个来源，决定这个位置更应该参考哪一种信息。
+得到融合 context 后，FiLM 的 gamma 和 beta 对视觉通道做缩放和平移，Spatial Gate 再决定当前空间位置和月份接受多少调制，最后通过 residual strength 写回 decoder 前特征。E9 和 E10 使用相同的 3D-Aware、M1 到 M4、训练协议和插入点，唯一变化就是融合架构，因此它们构成最严格的架构对照。</a:t>
             </a:r>
             <a:endParaRPr lang="en-US" dirty="0"/>
           </a:p>
@@ -1401,7 +1411,8 @@
           <a:p>
             <a:r>
               <a:rPr lang="en-US" dirty="0"/>
-              <a:t/>
+              <a:t>E10 的 Test mIoU 是 0.60073。相对四源 CA-HPI 的 E9，提高 0.678 个百分点，说明来源分层和空间—通道调制确实缓解了四源直接竞争造成的退化。相对无先验 B0，E10 只提高 0.128 个百分点；相对 M1-only 的 E7，仍低 0.370 个百分点。
+因此不能把 E10 讲成全面超过前面方案。更准确的结论是：融合架构会明显改变多源先验的边际收益，但先验仍然具有类别选择性。即使总体增益有限，我们已经建立了从先验表示、来源选择、特征调制到诊断的完整模式，也明确了它在强视觉基线上的适用边界。</a:t>
             </a:r>
             <a:endParaRPr lang="en-US" dirty="0"/>
           </a:p>
@@ -1489,7 +1500,8 @@
           <a:p>
             <a:r>
               <a:rPr lang="en-US" dirty="0"/>
-              <a:t/>
+              <a:t>农业监测需要知道一个区域种了什么、分布在哪里，而且这张图需要随着种植季更新。田间调查很难高频覆盖大范围，单景卫星影像也容易受到观测时间、云层和天气的影响。
+多时相 Sentinel-2 影像提供了另一种可能：同一块地在一年中的变化可以被连续记录下来。对作物来说，这些变化本身就是信息。因此我们研究的不是普通单图分类，而是卫星影像时间序列上的像素级识别。PASTIS 给出了月度时序影像和 19 类像素标签，正好可以同时研究生长季动态和地块边界。</a:t>
             </a:r>
             <a:endParaRPr lang="en-US" dirty="0"/>
           </a:p>
@@ -1577,7 +1589,9 @@
           <a:p>
             <a:r>
               <a:rPr lang="en-US" dirty="0"/>
-              <a:t/>
+              <a:t>最后把项目成果分成两条主线。第一条是性能和任务线：从输入协议与 token 语义审计开始，逐步比较空间读取和时间融合，最终用 3D-Aware 建立 0.59945 mIoU 的强视觉基线。第二条是方法线：把物候、气候、土壤和地理整理为 PriorBatch，从 V1 的固定广播推进到 CA-HPI 的内容感知查询，再到 SA-SFiLM 的来源感知调制，并用 E7 到 E10 的总体和逐类结果说明收益边界。
+E10 没有形成大幅总体提升，但这不等于先验阶段没有成果。我们已经建立了一套能够描述先验、接入先验、选择先验并诊断效果的模式，也知道多源先验为什么会冲突、架构重设计能改善什么、仍然解决不了什么。F1 和 F2 只有在出现稳定、可解释结果时才补入主汇报，否则作为后续方向。
+总体来看，本项目既形成了明确的时间融合性能成果，也完成了异构先验注入模式的连续探索。我们的最终结论不是简单的加先验就涨分，而是先验的来源、类别与融合架构共同决定它的作用边界。我的汇报到这里，谢谢大家。</a:t>
             </a:r>
             <a:endParaRPr lang="en-US" dirty="0"/>
           </a:p>
@@ -1665,7 +1679,8 @@
           <a:p>
             <a:r>
               <a:rPr lang="en-US" dirty="0"/>
-              <a:t/>
+              <a:t>这项工作的意义不只是再训练一个分割模型。应用上，我们希望让大范围作物制图更充分地利用完整生长季信息；科学上，我们关心一个冻结的遥感基础模型已经学到的多光谱、多层和多时间表征，怎样才能被下游像素级任务真正使用。
+方法上还存在一个更难的问题：农业知识的形式并不统一。物候是类别和月份的关系，气候是连续时间序列，土壤和地理又是另一种粒度。它们不能简单拼接，所以我们希望把先验的表示、选择、调制和诊断连成一套可复用方式。Galileo 提供了通用表征，但不会自动完成下游 token 读取和异构知识注入。</a:t>
             </a:r>
             <a:endParaRPr lang="en-US" dirty="0"/>
           </a:p>
@@ -1753,7 +1768,8 @@
           <a:p>
             <a:r>
               <a:rPr lang="en-US" dirty="0"/>
-              <a:t/>
+              <a:t>基于前面的背景，我们把问题具体化为三个层次。第一，Galileo 输出的是 token，PASTIS 需要的是与地块边界对齐的像素图，中间需要可靠的空间读取过程。第二，12 个月虽然一起进入 encoder，但如果在 decoder 前固定平均，月份身份可能丢失，所以要研究时间维保留到哪里、什么时候压缩。第三，在视觉时间信息已经被充分利用之后，物候、气候、土壤和地理知识还能不能提供独立补充。
+这个顺序很重要：先把视觉表征读好，再讨论外部知识。这样后面的先验结果才不会被输入错误、空间恢复不足或较弱的时间模型混淆。</a:t>
             </a:r>
             <a:endParaRPr lang="en-US" dirty="0"/>
           </a:p>
@@ -1841,7 +1857,8 @@
           <a:p>
             <a:r>
               <a:rPr lang="en-US" dirty="0"/>
-              <a:t/>
+              <a:t>具体研究流程是一条逐步加复杂度的路线。我们先对齐 PASTIS 和 Galileo 的输入协议，建立共享的冻结特征缓存；然后比较空间 decoder，再比较时间读取方式；在 3D-Aware 形成强视觉基线之后，才接入物候、气候、土壤和地理先验。每一步只增加一个新的问题，最终同时检查总体指标、逐类结果和模块诊断。
+数据划分始终固定：train 使用 folds 1、2、3，fold4 选择 checkpoint，fold5 只做最终测试。项目早期结果偏低时，我们先审计了作物年、归一化和 token 的空间—时间—通道语义，并建立 spatial_v1 和 temporal_v2 缓存。后续比较都建立在这条统一链路上。</a:t>
             </a:r>
             <a:endParaRPr lang="en-US" dirty="0"/>
           </a:p>
@@ -1929,7 +1946,8 @@
           <a:p>
             <a:r>
               <a:rPr lang="en-US" dirty="0"/>
-              <a:t/>
+              <a:t>先看空间读取。相同协议下，Linear Head 的 Test mIoU 是 0.3209；加入卷积细化以后达到 0.4602；再把第 3、6、9、12 层一起读入，达到 0.4801。最终层卷积相对 Linear 提升约 13.92 个百分点，多层读取又继续提升约 1.99 个百分点。
+这说明 Galileo 的冻结特征确实包含可迁移的作物信息，但 token 的线性可分性并不等于像素级边界能够直接恢复，中间层也提供了一些补充。这里不同方案的参数量和 seed 并不完全受控，所以我们把它作为空间读取阶段的证据，不把全部差异归因于某一个单独模块。</a:t>
             </a:r>
             <a:endParaRPr lang="en-US" dirty="0"/>
           </a:p>
@@ -2017,7 +2035,8 @@
           <a:p>
             <a:r>
               <a:rPr lang="en-US" dirty="0"/>
-              <a:t/>
+              <a:t>这里有一个容易混淆的地方：旧方案并不是没有时间信息，而是把时间压缩得太早。12 个月会一起进入 Galileo，所以每个月的 token 已经包含 encoder 内的跨时间上下文。
+真正的限制发生在 decoder 前，我们直接对 12 个月做固定平均。这样 decoder 只看到一张二维特征图，不能再根据空间位置、网络层次和作物类型判断哪个月份更重要。于是接下来要回答的问题就是：时间维应该保留到哪里，最后又应该怎样压缩。</a:t>
             </a:r>
             <a:endParaRPr lang="en-US" dirty="0"/>
           </a:p>
@@ -2105,7 +2124,8 @@
           <a:p>
             <a:r>
               <a:rPr lang="en-US" dirty="0"/>
-              <a:t/>
+              <a:t>我们沿着这个问题设计了两条路线。Temporal Readout 放在 decoder 前，让每一层、每个空间位置自己学习 12 个月的权重，后面的二维 decoder 不需要修改，所以它更像一个通用的时间读取接口。
+3D-Aware 则把时间维带进多层重组和高分辨率空间融合，最后才通过 query pooling 得到分割结果。两条路线的区别可以简单理解为：一个学习怎样读取月份，另一个把时间保留得更久再做空间融合。它们都在检验同一个判断——时间不应该在 decoder 前被固定平均。</a:t>
             </a:r>
             <a:endParaRPr lang="en-US" dirty="0"/>
           </a:p>
@@ -2193,7 +2213,8 @@
           <a:p>
             <a:r>
               <a:rPr lang="en-US" dirty="0"/>
-              <a:t/>
+              <a:t>先看 Temporal Readout。它接到四种二维 decoder 上后，Test mIoU 都在 0.54 到 0.56 之间，其中 Multi 最高，为 0.56154。这说明可学习月份读取并不依赖某一个特定 decoder。
+再看 3D-Aware，无先验基线的 Test mIoU 达到 0.59945，macro F1 是 0.73133。这是项目最明确的性能成果，也说明时间读取方式是关键变量。后面的先验实验固定使用这个 3D-Aware 强视觉基线，避免先验收益被较弱的视觉模型放大或掩盖。</a:t>
             </a:r>
             <a:endParaRPr lang="en-US" dirty="0"/>
           </a:p>
@@ -3864,7 +3885,7 @@
       </p:sp>
       <p:sp>
         <p:nvSpPr>
-          <p:cNvPr id="11" name="Shape 8"/>
+          <p:cNvPr id="12" name="Shape 8"/>
           <p:cNvSpPr/>
           <p:nvPr/>
         </p:nvSpPr>
@@ -3889,7 +3910,7 @@
       </p:sp>
       <p:sp>
         <p:nvSpPr>
-          <p:cNvPr id="12" name="Shape 9"/>
+          <p:cNvPr id="13" name="Shape 9"/>
           <p:cNvSpPr/>
           <p:nvPr/>
         </p:nvSpPr>
@@ -3914,7 +3935,7 @@
       </p:sp>
       <p:sp>
         <p:nvSpPr>
-          <p:cNvPr id="13" name="Text 10"/>
+          <p:cNvPr id="14" name="Text 10"/>
           <p:cNvSpPr txBox="1"/>
           <p:nvPr/>
         </p:nvSpPr>
@@ -4540,7 +4561,7 @@
       </p:sp>
       <p:sp>
         <p:nvSpPr>
-          <p:cNvPr id="18" name="Shape 15"/>
+          <p:cNvPr id="19" name="Shape 15"/>
           <p:cNvSpPr/>
           <p:nvPr/>
         </p:nvSpPr>
@@ -4565,7 +4586,7 @@
       </p:sp>
       <p:sp>
         <p:nvSpPr>
-          <p:cNvPr id="19" name="Shape 16"/>
+          <p:cNvPr id="20" name="Shape 16"/>
           <p:cNvSpPr/>
           <p:nvPr/>
         </p:nvSpPr>
@@ -4590,7 +4611,7 @@
       </p:sp>
       <p:sp>
         <p:nvSpPr>
-          <p:cNvPr id="20" name="Text 17"/>
+          <p:cNvPr id="21" name="Text 17"/>
           <p:cNvSpPr txBox="1"/>
           <p:nvPr/>
         </p:nvSpPr>
@@ -5216,7 +5237,7 @@
       </p:sp>
       <p:sp>
         <p:nvSpPr>
-          <p:cNvPr id="18" name="Shape 15"/>
+          <p:cNvPr id="19" name="Shape 15"/>
           <p:cNvSpPr/>
           <p:nvPr/>
         </p:nvSpPr>
@@ -5241,7 +5262,7 @@
       </p:sp>
       <p:sp>
         <p:nvSpPr>
-          <p:cNvPr id="19" name="Shape 16"/>
+          <p:cNvPr id="20" name="Shape 16"/>
           <p:cNvSpPr/>
           <p:nvPr/>
         </p:nvSpPr>
@@ -5266,7 +5287,7 @@
       </p:sp>
       <p:sp>
         <p:nvSpPr>
-          <p:cNvPr id="20" name="Text 17"/>
+          <p:cNvPr id="21" name="Text 17"/>
           <p:cNvSpPr txBox="1"/>
           <p:nvPr/>
         </p:nvSpPr>
@@ -5892,7 +5913,7 @@
       </p:sp>
       <p:sp>
         <p:nvSpPr>
-          <p:cNvPr id="18" name="Shape 15"/>
+          <p:cNvPr id="19" name="Shape 15"/>
           <p:cNvSpPr/>
           <p:nvPr/>
         </p:nvSpPr>
@@ -5917,7 +5938,7 @@
       </p:sp>
       <p:sp>
         <p:nvSpPr>
-          <p:cNvPr id="19" name="Shape 16"/>
+          <p:cNvPr id="20" name="Shape 16"/>
           <p:cNvSpPr/>
           <p:nvPr/>
         </p:nvSpPr>
@@ -5942,7 +5963,7 @@
       </p:sp>
       <p:sp>
         <p:nvSpPr>
-          <p:cNvPr id="20" name="Text 17"/>
+          <p:cNvPr id="21" name="Text 17"/>
           <p:cNvSpPr txBox="1"/>
           <p:nvPr/>
         </p:nvSpPr>
@@ -10640,7 +10661,7 @@
       </p:sp>
       <p:sp>
         <p:nvSpPr>
-          <p:cNvPr id="10" name="Shape 7"/>
+          <p:cNvPr id="11" name="Shape 7"/>
           <p:cNvSpPr/>
           <p:nvPr/>
         </p:nvSpPr>
@@ -10665,7 +10686,7 @@
       </p:sp>
       <p:sp>
         <p:nvSpPr>
-          <p:cNvPr id="11" name="Shape 8"/>
+          <p:cNvPr id="12" name="Shape 8"/>
           <p:cNvSpPr/>
           <p:nvPr/>
         </p:nvSpPr>
@@ -10690,7 +10711,7 @@
       </p:sp>
       <p:sp>
         <p:nvSpPr>
-          <p:cNvPr id="12" name="Text 9"/>
+          <p:cNvPr id="13" name="Text 9"/>
           <p:cNvSpPr txBox="1"/>
           <p:nvPr/>
         </p:nvSpPr>
@@ -12890,7 +12911,7 @@
       </p:sp>
       <p:sp>
         <p:nvSpPr>
-          <p:cNvPr id="10" name="Shape 7"/>
+          <p:cNvPr id="11" name="Shape 7"/>
           <p:cNvSpPr/>
           <p:nvPr/>
         </p:nvSpPr>
@@ -12915,7 +12936,7 @@
       </p:sp>
       <p:sp>
         <p:nvSpPr>
-          <p:cNvPr id="11" name="Shape 8"/>
+          <p:cNvPr id="12" name="Shape 8"/>
           <p:cNvSpPr/>
           <p:nvPr/>
         </p:nvSpPr>
@@ -12940,7 +12961,7 @@
       </p:sp>
       <p:sp>
         <p:nvSpPr>
-          <p:cNvPr id="12" name="Text 9"/>
+          <p:cNvPr id="13" name="Text 9"/>
           <p:cNvSpPr txBox="1"/>
           <p:nvPr/>
         </p:nvSpPr>
@@ -15140,7 +15161,7 @@
       </p:sp>
       <p:sp>
         <p:nvSpPr>
-          <p:cNvPr id="10" name="Shape 7"/>
+          <p:cNvPr id="11" name="Shape 7"/>
           <p:cNvSpPr/>
           <p:nvPr/>
         </p:nvSpPr>
@@ -15165,7 +15186,7 @@
       </p:sp>
       <p:sp>
         <p:nvSpPr>
-          <p:cNvPr id="11" name="Shape 8"/>
+          <p:cNvPr id="12" name="Shape 8"/>
           <p:cNvSpPr/>
           <p:nvPr/>
         </p:nvSpPr>
@@ -15190,7 +15211,7 @@
       </p:sp>
       <p:sp>
         <p:nvSpPr>
-          <p:cNvPr id="12" name="Text 9"/>
+          <p:cNvPr id="13" name="Text 9"/>
           <p:cNvSpPr txBox="1"/>
           <p:nvPr/>
         </p:nvSpPr>
@@ -15816,7 +15837,7 @@
       </p:sp>
       <p:sp>
         <p:nvSpPr>
-          <p:cNvPr id="18" name="Shape 15"/>
+          <p:cNvPr id="19" name="Shape 15"/>
           <p:cNvSpPr/>
           <p:nvPr/>
         </p:nvSpPr>
@@ -15841,7 +15862,7 @@
       </p:sp>
       <p:sp>
         <p:nvSpPr>
-          <p:cNvPr id="19" name="Shape 16"/>
+          <p:cNvPr id="20" name="Shape 16"/>
           <p:cNvSpPr/>
           <p:nvPr/>
         </p:nvSpPr>
@@ -15866,7 +15887,7 @@
       </p:sp>
       <p:sp>
         <p:nvSpPr>
-          <p:cNvPr id="20" name="Text 17"/>
+          <p:cNvPr id="21" name="Text 17"/>
           <p:cNvSpPr txBox="1"/>
           <p:nvPr/>
         </p:nvSpPr>
@@ -18831,7 +18852,7 @@
       </p:sp>
       <p:sp>
         <p:nvSpPr>
-          <p:cNvPr id="11" name="Shape 8"/>
+          <p:cNvPr id="12" name="Shape 8"/>
           <p:cNvSpPr/>
           <p:nvPr/>
         </p:nvSpPr>
@@ -18856,7 +18877,7 @@
       </p:sp>
       <p:sp>
         <p:nvSpPr>
-          <p:cNvPr id="12" name="Shape 9"/>
+          <p:cNvPr id="13" name="Shape 9"/>
           <p:cNvSpPr/>
           <p:nvPr/>
         </p:nvSpPr>
@@ -18881,7 +18902,7 @@
       </p:sp>
       <p:sp>
         <p:nvSpPr>
-          <p:cNvPr id="13" name="Text 10"/>
+          <p:cNvPr id="14" name="Text 10"/>
           <p:cNvSpPr txBox="1"/>
           <p:nvPr/>
         </p:nvSpPr>
@@ -21363,7 +21384,7 @@
       </p:sp>
       <p:sp>
         <p:nvSpPr>
-          <p:cNvPr id="18" name="Shape 15"/>
+          <p:cNvPr id="19" name="Shape 15"/>
           <p:cNvSpPr/>
           <p:nvPr/>
         </p:nvSpPr>
@@ -21388,7 +21409,7 @@
       </p:sp>
       <p:sp>
         <p:nvSpPr>
-          <p:cNvPr id="19" name="Shape 16"/>
+          <p:cNvPr id="20" name="Shape 16"/>
           <p:cNvSpPr/>
           <p:nvPr/>
         </p:nvSpPr>
@@ -21413,7 +21434,7 @@
       </p:sp>
       <p:sp>
         <p:nvSpPr>
-          <p:cNvPr id="20" name="Text 17"/>
+          <p:cNvPr id="21" name="Text 17"/>
           <p:cNvSpPr txBox="1"/>
           <p:nvPr/>
         </p:nvSpPr>
@@ -22039,7 +22060,7 @@
       </p:sp>
       <p:sp>
         <p:nvSpPr>
-          <p:cNvPr id="18" name="Shape 15"/>
+          <p:cNvPr id="19" name="Shape 15"/>
           <p:cNvSpPr/>
           <p:nvPr/>
         </p:nvSpPr>
@@ -22064,7 +22085,7 @@
       </p:sp>
       <p:sp>
         <p:nvSpPr>
-          <p:cNvPr id="19" name="Shape 16"/>
+          <p:cNvPr id="20" name="Shape 16"/>
           <p:cNvSpPr/>
           <p:nvPr/>
         </p:nvSpPr>
@@ -22089,7 +22110,7 @@
       </p:sp>
       <p:sp>
         <p:nvSpPr>
-          <p:cNvPr id="20" name="Text 17"/>
+          <p:cNvPr id="21" name="Text 17"/>
           <p:cNvSpPr txBox="1"/>
           <p:nvPr/>
         </p:nvSpPr>
@@ -23806,7 +23827,7 @@
       </p:sp>
       <p:sp>
         <p:nvSpPr>
-          <p:cNvPr id="18" name="Shape 15"/>
+          <p:cNvPr id="19" name="Shape 15"/>
           <p:cNvSpPr/>
           <p:nvPr/>
         </p:nvSpPr>
@@ -23831,7 +23852,7 @@
       </p:sp>
       <p:sp>
         <p:nvSpPr>
-          <p:cNvPr id="19" name="Shape 16"/>
+          <p:cNvPr id="20" name="Shape 16"/>
           <p:cNvSpPr/>
           <p:nvPr/>
         </p:nvSpPr>
@@ -23856,7 +23877,7 @@
       </p:sp>
       <p:sp>
         <p:nvSpPr>
-          <p:cNvPr id="20" name="Text 17"/>
+          <p:cNvPr id="21" name="Text 17"/>
           <p:cNvSpPr txBox="1"/>
           <p:nvPr/>
         </p:nvSpPr>
@@ -24482,7 +24503,7 @@
       </p:sp>
       <p:sp>
         <p:nvSpPr>
-          <p:cNvPr id="18" name="Shape 15"/>
+          <p:cNvPr id="19" name="Shape 15"/>
           <p:cNvSpPr/>
           <p:nvPr/>
         </p:nvSpPr>
@@ -24507,7 +24528,7 @@
       </p:sp>
       <p:sp>
         <p:nvSpPr>
-          <p:cNvPr id="19" name="Shape 16"/>
+          <p:cNvPr id="20" name="Shape 16"/>
           <p:cNvSpPr/>
           <p:nvPr/>
         </p:nvSpPr>
@@ -24532,7 +24553,7 @@
       </p:sp>
       <p:sp>
         <p:nvSpPr>
-          <p:cNvPr id="20" name="Text 17"/>
+          <p:cNvPr id="21" name="Text 17"/>
           <p:cNvSpPr txBox="1"/>
           <p:nvPr/>
         </p:nvSpPr>

</xml_diff>

<commit_message>
docs: strengthen final presentation research background
</commit_message>
<xml_diff>
--- a/final_presentation/PROJECT_CONCLUSION_DECK_2026-07-22.pptx
+++ b/final_presentation/PROJECT_CONCLUSION_DECK_2026-07-22.pptx
@@ -521,8 +521,8 @@
           <a:p>
             <a:r>
               <a:rPr lang="en-US" dirty="0"/>
-              <a:t>大家好，我们汇报的题目是《从遥感基础表征读取到异构先验注入》。这项工作研究 Galileo 遥感基础模型在 PASTIS 作物时序分割任务上的迁移。我们把 Galileo 的 encoder 冻结下来，先研究它学到的空间和时间信息怎样被下游网络读出来，再进一步看物候、气候、土壤和地理知识能不能提供视觉信息之外的补充。
-这次汇报不按模型清单来讲，而是按照研究问题怎样一步步形成来讲。我们先从任务背景和意义开始，再进入空间读取、时间融合和异构先验注入。首先看为什么作物识别需要一整年的观测。</a:t>
+              <a:t>大家好，我们的项目是《基于预训练自监督模型的时序农田遥感作物分割》。我们关注的是一个很实际的问题：在农业像素级标注有限的情况下，怎样利用遥感基础模型和完整生长季影像，得到可靠的作物类型地图。
+项目以 PASTIS 作物时序分割为任务，以冻结的 Galileo 自监督编码器为表征基础，沿着两条问题链展开。第一条研究多层、多时刻特征怎样被 decoder 有效读取，最终形成 3D-Aware DPT；第二条研究物候、气候、土壤和地理等异构农业知识怎样进入视觉网络，最终形成 CA-HPI 和 SA-SFiLM。下面先从农业遥感为什么需要这项研究讲起。</a:t>
             </a:r>
             <a:endParaRPr lang="en-US" dirty="0"/>
           </a:p>
@@ -1500,8 +1500,8 @@
           <a:p>
             <a:r>
               <a:rPr lang="en-US" dirty="0"/>
-              <a:t>农业监测需要知道一个区域种了什么、分布在哪里，而且这张图需要随着种植季更新。田间调查很难高频覆盖大范围，单景卫星影像也容易受到观测时间、云层和天气的影响。
-多时相 Sentinel-2 影像提供了另一种可能：同一块地在一年中的变化可以被连续记录下来。对作物来说，这些变化本身就是信息。因此我们研究的不是普通单图分类，而是卫星影像时间序列上的像素级识别。PASTIS 给出了月度时序影像和 19 类像素标签，正好可以同时研究生长季动态和地块边界。</a:t>
+              <a:t>精准农业首先需要一张可信的作物类型空间分布图。产量估算、轮作监测、水资源调度和农业补贴核查，都要以这张基础数据层为起点。区域尺度上，卫星遥感凭借覆盖广、重复观测和成本低，基本是持续更新作物地图的可行路径。
+Sentinel-2 提供 10 米空间分辨率、约 5 天重访周期和多光谱观测，可以把同一地块一整年的变化记录下来。这个时间维很关键，因为不同作物在播种、生长和收获阶段会形成不同的时间谱线；只看单期影像，即使加入 NDVI 等手工特征，也容易混淆物候相近的类别。与此同时，像素级农业标注需要田间调查或专家解译，获取成本很高。我们因此面对一个核心矛盾：既要保留全年物候动态和地块边界，又不能依赖无限扩张的人工标注。PASTIS 正好提供了法国 2018 到 2019 作物年的 Sentinel-2 时序与 18 类作物加背景标签，作为统一验证平台。</a:t>
             </a:r>
             <a:endParaRPr lang="en-US" dirty="0"/>
           </a:p>
@@ -1679,8 +1679,9 @@
           <a:p>
             <a:r>
               <a:rPr lang="en-US" dirty="0"/>
-              <a:t>这项工作的意义不只是再训练一个分割模型。应用上，我们希望让大范围作物制图更充分地利用完整生长季信息；科学上，我们关心一个冻结的遥感基础模型已经学到的多光谱、多层和多时间表征，怎样才能被下游像素级任务真正使用。
-方法上还存在一个更难的问题：农业知识的形式并不统一。物候是类别和月份的关系，气候是连续时间序列，土壤和地理又是另一种粒度。它们不能简单拼接，所以我们希望把先验的表示、选择、调制和诊断连成一套可复用方式。Galileo 提供了通用表征，但不会自动完成下游 token 读取和异构知识注入。</a:t>
+              <a:t>传统路线首先依靠单时相影像、NDVI 等手工特征，再用随机森林或支持向量机分类；后来 ConvLSTM、TempCNN 和 Transformer 提升了时序建模能力，但它们仍然围绕具体任务和人工标签训练。对于农业分割来说，像素级标注的成本决定了这种路线很难无限扩展。
+自监督学习提供了新的入口。它通过掩码建模或对比学习，从大量无标签数据中先学通用表征，再迁移到下游任务。Galileo 就是面向卫星时序数据的基础模型：它以 ViT 为骨干，在大规模全球 Sentinel-2 数据上进行掩码图像建模，输出多层、多时刻、可迁移的时空 token。于是我们可以采用冻结 encoder 加轻量 decoder 的范式，把有限标注主要用在下游读取。
+但基础模型只解决了表征从哪里来，并没有自动回答两个问题：这些多尺度、多时刻 token 怎样恢复成高分辨率作物地图，以及物候、气候、土壤和地理等外部知识怎样与视觉特征交互。这正是本项目继续研究的部分。</a:t>
             </a:r>
             <a:endParaRPr lang="en-US" dirty="0"/>
           </a:p>
@@ -2882,7 +2883,7 @@
                 <a:ea typeface="Microsoft YaHei" pitchFamily="34" charset="-122"/>
                 <a:cs typeface="Microsoft YaHei" pitchFamily="34" charset="-120"/>
               </a:rPr>
-              <a:t>PROJECT CONCLUSION · 2026-07</a:t>
+              <a:t>PROJECT CONCLUSION · 2026</a:t>
             </a:r>
             <a:endParaRPr lang="en-US" sz="840" dirty="0"/>
           </a:p>
@@ -2923,7 +2924,7 @@
                 <a:ea typeface="Microsoft YaHei" pitchFamily="34" charset="-122"/>
                 <a:cs typeface="Microsoft YaHei" pitchFamily="34" charset="-120"/>
               </a:rPr>
-              <a:t>从遥感基础表征读取到</a:t>
+              <a:t>基于预训练自监督模型的</a:t>
             </a:r>
             <a:endParaRPr lang="en-US" sz="4200" dirty="0"/>
           </a:p>
@@ -2940,7 +2941,7 @@
                 <a:ea typeface="Microsoft YaHei" pitchFamily="34" charset="-122"/>
                 <a:cs typeface="Microsoft YaHei" pitchFamily="34" charset="-120"/>
               </a:rPr>
-              <a:t>异构先验注入</a:t>
+              <a:t>时序农田遥感作物分割</a:t>
             </a:r>
             <a:endParaRPr lang="en-US" sz="4200" dirty="0"/>
           </a:p>
@@ -3006,7 +3007,7 @@
                 <a:ea typeface="Microsoft YaHei" pitchFamily="34" charset="-122"/>
                 <a:cs typeface="Microsoft YaHei" pitchFamily="34" charset="-120"/>
               </a:rPr>
-              <a:t>基于 frozen Galileo 的 PASTIS 作物时序分割研究</a:t>
+              <a:t>从冻结 Galileo 时空表征读取到异构先验注入</a:t>
             </a:r>
             <a:endParaRPr lang="en-US" sz="1400" dirty="0"/>
           </a:p>
@@ -18069,7 +18070,7 @@
                 <a:ea typeface="Microsoft YaHei" pitchFamily="34" charset="-122"/>
                 <a:cs typeface="Microsoft YaHei" pitchFamily="34" charset="-120"/>
               </a:rPr>
-              <a:t>大范围农业监测需要持续、精细的作物类型信息</a:t>
+              <a:t>农业遥感需要把全年动态转化为地块级作物地图</a:t>
             </a:r>
             <a:endParaRPr lang="en-US" sz="2600" dirty="0"/>
           </a:p>
@@ -18108,7 +18109,7 @@
                 <a:ea typeface="Microsoft YaHei" pitchFamily="34" charset="-122"/>
                 <a:cs typeface="Microsoft YaHei" pitchFamily="34" charset="-120"/>
               </a:rPr>
-              <a:t>作物制图不是普通单图分类，而是时间序列上的像素级识别</a:t>
+              <a:t>Sentinel-2 提供高频多光谱时序，但单期识别和高成本标注仍是瓶颈</a:t>
             </a:r>
             <a:endParaRPr lang="en-US" sz="1300" dirty="0"/>
           </a:p>
@@ -18160,9 +18161,9 @@
             <a:tbl>
               <a:tblPr/>
               <a:tblGrid>
-                <a:gridCol w="1898401"/>
-                <a:gridCol w="2882757"/>
-                <a:gridCol w="2460890"/>
+                <a:gridCol w="2414016"/>
+                <a:gridCol w="2414016"/>
+                <a:gridCol w="2414016"/>
               </a:tblGrid>
               <a:tr h="329184">
                 <a:tc>
@@ -18182,7 +18183,7 @@
                           <a:ea typeface="Microsoft YaHei" pitchFamily="34" charset="-122"/>
                           <a:cs typeface="Microsoft YaHei" pitchFamily="34" charset="-120"/>
                         </a:rPr>
-                        <a:t>农业信息需求</a:t>
+                        <a:t>作物地图为什么重要</a:t>
                       </a:r>
                       <a:endParaRPr lang="en-US" sz="980" dirty="0">
                         <a:latin typeface="Microsoft YaHei" charset="0"/>
@@ -18226,7 +18227,7 @@
                           <a:ea typeface="Microsoft YaHei" pitchFamily="34" charset="-122"/>
                           <a:cs typeface="Microsoft YaHei" pitchFamily="34" charset="-120"/>
                         </a:rPr>
-                        <a:t>传统获取限制</a:t>
+                        <a:t>为什么必须看时序</a:t>
                       </a:r>
                       <a:endParaRPr lang="en-US" sz="980" dirty="0">
                         <a:latin typeface="Microsoft YaHei" charset="0"/>
@@ -18270,7 +18271,7 @@
                           <a:ea typeface="Microsoft YaHei" pitchFamily="34" charset="-122"/>
                           <a:cs typeface="Microsoft YaHei" pitchFamily="34" charset="-120"/>
                         </a:rPr>
-                        <a:t>卫星时间序列提供的机会</a:t>
+                        <a:t>传统路线的瓶颈</a:t>
                       </a:r>
                       <a:endParaRPr lang="en-US" sz="980" dirty="0">
                         <a:latin typeface="Microsoft YaHei" charset="0"/>
@@ -18316,7 +18317,7 @@
                           <a:ea typeface="Microsoft YaHei" pitchFamily="34" charset="-122"/>
                           <a:cs typeface="Microsoft YaHei" pitchFamily="34" charset="-120"/>
                         </a:rPr>
-                        <a:t>种植结构与空间分布</a:t>
+                        <a:t>产量估算、轮作监测与水资源调度的基础数据层</a:t>
                       </a:r>
                       <a:endParaRPr lang="en-US" sz="890" dirty="0">
                         <a:latin typeface="Microsoft YaHei" charset="0"/>
@@ -18360,7 +18361,7 @@
                           <a:ea typeface="Microsoft YaHei" pitchFamily="34" charset="-122"/>
                           <a:cs typeface="Microsoft YaHei" pitchFamily="34" charset="-120"/>
                         </a:rPr>
-                        <a:t>田间调查成本高、更新频率有限</a:t>
+                        <a:t>Sentinel-2：10 m、约 5 天重访、多光谱连续观测</a:t>
                       </a:r>
                       <a:endParaRPr lang="en-US" sz="890" dirty="0">
                         <a:latin typeface="Microsoft YaHei" charset="0"/>
@@ -18404,7 +18405,7 @@
                           <a:ea typeface="Microsoft YaHei" pitchFamily="34" charset="-122"/>
                           <a:cs typeface="Microsoft YaHei" pitchFamily="34" charset="-120"/>
                         </a:rPr>
-                        <a:t>大范围、重复观测</a:t>
+                        <a:t>田间调查和专家解译成本高，难以高频更新</a:t>
                       </a:r>
                       <a:endParaRPr lang="en-US" sz="890" dirty="0">
                         <a:latin typeface="Microsoft YaHei" charset="0"/>
@@ -18450,7 +18451,7 @@
                           <a:ea typeface="Microsoft YaHei" pitchFamily="34" charset="-122"/>
                           <a:cs typeface="Microsoft YaHei" pitchFamily="34" charset="-120"/>
                         </a:rPr>
-                        <a:t>地块尺度类别与边界</a:t>
+                        <a:t>区域尺度需要大范围、周期性、低成本制图</a:t>
                       </a:r>
                       <a:endParaRPr lang="en-US" sz="890" dirty="0">
                         <a:latin typeface="Microsoft YaHei" charset="0"/>
@@ -18494,7 +18495,7 @@
                           <a:ea typeface="Microsoft YaHei" pitchFamily="34" charset="-122"/>
                           <a:cs typeface="Microsoft YaHei" pitchFamily="34" charset="-120"/>
                         </a:rPr>
-                        <a:t>汇总统计难以提供连续空间结果</a:t>
+                        <a:t>不同作物在生长季形成独特的时间谱线</a:t>
                       </a:r>
                       <a:endParaRPr lang="en-US" sz="890" dirty="0">
                         <a:latin typeface="Microsoft YaHei" charset="0"/>
@@ -18538,7 +18539,7 @@
                           <a:ea typeface="Microsoft YaHei" pitchFamily="34" charset="-122"/>
                           <a:cs typeface="Microsoft YaHei" pitchFamily="34" charset="-120"/>
                         </a:rPr>
-                        <a:t>像素级制图与区域统计</a:t>
+                        <a:t>单时相 + 手工植被指数容易忽略物候动态</a:t>
                       </a:r>
                       <a:endParaRPr lang="en-US" sz="890" dirty="0">
                         <a:latin typeface="Microsoft YaHei" charset="0"/>
@@ -18584,7 +18585,7 @@
                           <a:ea typeface="Microsoft YaHei" pitchFamily="34" charset="-122"/>
                           <a:cs typeface="Microsoft YaHei" pitchFamily="34" charset="-120"/>
                         </a:rPr>
-                        <a:t>生长季内的动态变化</a:t>
+                        <a:t>最终结果需要与地块边界对齐的像素级类别图</a:t>
                       </a:r>
                       <a:endParaRPr lang="en-US" sz="890" dirty="0">
                         <a:latin typeface="Microsoft YaHei" charset="0"/>
@@ -18628,7 +18629,7 @@
                           <a:ea typeface="Microsoft YaHei" pitchFamily="34" charset="-122"/>
                           <a:cs typeface="Microsoft YaHei" pitchFamily="34" charset="-120"/>
                         </a:rPr>
-                        <a:t>单次调查或单景影像容易遗漏过程</a:t>
+                        <a:t>全年曲线有助区分物候相近的作物类型</a:t>
                       </a:r>
                       <a:endParaRPr lang="en-US" sz="890" dirty="0">
                         <a:latin typeface="Microsoft YaHei" charset="0"/>
@@ -18672,7 +18673,7 @@
                           <a:ea typeface="Microsoft YaHei" pitchFamily="34" charset="-122"/>
                           <a:cs typeface="Microsoft YaHei" pitchFamily="34" charset="-120"/>
                         </a:rPr>
-                        <a:t>多时相光谱记录生长轨迹</a:t>
+                        <a:t>深度时序模型仍受像素级标注稀缺限制</a:t>
                       </a:r>
                       <a:endParaRPr lang="en-US" sz="890" dirty="0">
                         <a:latin typeface="Microsoft YaHei" charset="0"/>
@@ -18739,7 +18740,7 @@
                 <a:ea typeface="Microsoft YaHei" pitchFamily="34" charset="-122"/>
                 <a:cs typeface="Microsoft YaHei" pitchFamily="34" charset="-120"/>
               </a:rPr>
-              <a:t>研究对象：PASTIS Sentinel-2 月度时间序列与 19 类像素标签。</a:t>
+              <a:t>研究对象：PASTIS，法国 2018–2019 作物年，18 类作物 + 背景的 Sentinel-2 月度时序分割。</a:t>
             </a:r>
             <a:endParaRPr lang="en-US" sz="900" dirty="0"/>
           </a:p>
@@ -18805,7 +18806,7 @@
                 <a:ea typeface="Microsoft YaHei" pitchFamily="34" charset="-122"/>
                 <a:cs typeface="Microsoft YaHei" pitchFamily="34" charset="-120"/>
               </a:rPr>
-              <a:t>Sources: [PASTIS21] [U-TAE]</a:t>
+              <a:t>Sources: [Sentinel-2] [PASTIS21] [U-TAE]</a:t>
             </a:r>
             <a:endParaRPr lang="en-US" sz="800" dirty="0"/>
           </a:p>
@@ -18935,7 +18936,7 @@
                 <a:ea typeface="Microsoft YaHei" pitchFamily="34" charset="-122"/>
                 <a:cs typeface="Microsoft YaHei" pitchFamily="34" charset="-120"/>
               </a:rPr>
-              <a:t>同一地块一年中的变化本身就是作物信息。</a:t>
+              <a:t>核心矛盾：既要保留全年物候动态与地块边界，又要降低对高成本像素标注的依赖。</a:t>
             </a:r>
             <a:endParaRPr lang="en-US" sz="920" dirty="0"/>
           </a:p>
@@ -20285,7 +20286,7 @@
                 <a:ea typeface="Microsoft YaHei" pitchFamily="34" charset="-122"/>
                 <a:cs typeface="Microsoft YaHei" pitchFamily="34" charset="-120"/>
               </a:rPr>
-              <a:t>把通用遥感表征真正转化为农业像素级结果</a:t>
+              <a:t>标注瓶颈推动遥感方法从任务监督走向自监督基础模型</a:t>
             </a:r>
             <a:endParaRPr lang="en-US" sz="2600" dirty="0"/>
           </a:p>
@@ -20324,7 +20325,7 @@
                 <a:ea typeface="Microsoft YaHei" pitchFamily="34" charset="-122"/>
                 <a:cs typeface="Microsoft YaHei" pitchFamily="34" charset="-120"/>
               </a:rPr>
-              <a:t>应用、科学与方法意义在同一个问题上汇合</a:t>
+              <a:t>Galileo 降低了通用表征学习对标签的依赖，但下游时空读取仍需重新设计</a:t>
             </a:r>
             <a:endParaRPr lang="en-US" sz="1300" dirty="0"/>
           </a:p>
@@ -20363,7 +20364,7 @@
                 <a:ea typeface="Microsoft YaHei" pitchFamily="34" charset="-122"/>
                 <a:cs typeface="Microsoft YaHei" pitchFamily="34" charset="-120"/>
               </a:rPr>
-              <a:t>现实与应用意义</a:t>
+              <a:t>传统监督路线与瓶颈</a:t>
             </a:r>
             <a:endParaRPr lang="en-US" sz="2400" dirty="0"/>
           </a:p>
@@ -20406,7 +20407,7 @@
                 <a:ea typeface="Microsoft YaHei" pitchFamily="34" charset="-122"/>
                 <a:cs typeface="Microsoft YaHei" pitchFamily="34" charset="-120"/>
               </a:rPr>
-              <a:t>大范围、低成本地更新作物类型地图</a:t>
+              <a:t>单时相 + 植被指数 + RF/SVM：依赖手工特征，忽略完整物候</a:t>
             </a:r>
             <a:endParaRPr lang="en-US" sz="1500" dirty="0"/>
           </a:p>
@@ -20427,7 +20428,7 @@
                 <a:ea typeface="Microsoft YaHei" pitchFamily="34" charset="-122"/>
                 <a:cs typeface="Microsoft YaHei" pitchFamily="34" charset="-120"/>
               </a:rPr>
-              <a:t>充分利用完整生长季，而非依赖单景影像</a:t>
+              <a:t>ConvLSTM、TempCNN、Transformer：增强时间建模，但仍依赖任务标注</a:t>
             </a:r>
             <a:endParaRPr lang="en-US" sz="1500" dirty="0"/>
           </a:p>
@@ -20448,7 +20449,7 @@
                 <a:ea typeface="Microsoft YaHei" pitchFamily="34" charset="-122"/>
                 <a:cs typeface="Microsoft YaHei" pitchFamily="34" charset="-120"/>
               </a:rPr>
-              <a:t>让基础模型表征服务于地块边界和区域统计</a:t>
+              <a:t>农业像素标签需要实地调查或专家解译，规模扩展成本高</a:t>
             </a:r>
             <a:endParaRPr lang="en-US" sz="1500" dirty="0"/>
           </a:p>
@@ -20487,7 +20488,7 @@
                 <a:ea typeface="Microsoft YaHei" pitchFamily="34" charset="-122"/>
                 <a:cs typeface="Microsoft YaHei" pitchFamily="34" charset="-120"/>
               </a:rPr>
-              <a:t>科学与方法意义</a:t>
+              <a:t>自监督预训练与 Galileo</a:t>
             </a:r>
             <a:endParaRPr lang="en-US" sz="2400" dirty="0"/>
           </a:p>
@@ -20530,7 +20531,7 @@
                 <a:ea typeface="Microsoft YaHei" pitchFamily="34" charset="-122"/>
                 <a:cs typeface="Microsoft YaHei" pitchFamily="34" charset="-120"/>
               </a:rPr>
-              <a:t>研究 frozen Galileo 的多层、多时间 token 如何迁移到 dense prediction</a:t>
+              <a:t>从大规模无标签 Sentinel-2 数据学习通用时空表征</a:t>
             </a:r>
             <a:endParaRPr lang="en-US" sz="1500" dirty="0"/>
           </a:p>
@@ -20551,7 +20552,7 @@
                 <a:ea typeface="Microsoft YaHei" pitchFamily="34" charset="-122"/>
                 <a:cs typeface="Microsoft YaHei" pitchFamily="34" charset="-120"/>
               </a:rPr>
-              <a:t>将物候、气候、土壤和地理整理为可插拔先验接口</a:t>
+              <a:t>ViT 输出多层、多时刻、可迁移的卫星时序 token</a:t>
             </a:r>
             <a:endParaRPr lang="en-US" sz="1500" dirty="0"/>
           </a:p>
@@ -20572,7 +20573,7 @@
                 <a:ea typeface="Microsoft YaHei" pitchFamily="34" charset="-122"/>
                 <a:cs typeface="Microsoft YaHei" pitchFamily="34" charset="-120"/>
               </a:rPr>
-              <a:t>把先验的表示、选择、调制和诊断连成一条通用模式</a:t>
+              <a:t>形成 frozen encoder + 轻量 decoder 的下游迁移范式</a:t>
             </a:r>
             <a:endParaRPr lang="en-US" sz="1500" dirty="0"/>
           </a:p>
@@ -20686,7 +20687,7 @@
                 <a:ea typeface="Microsoft YaHei" pitchFamily="34" charset="-122"/>
                 <a:cs typeface="Microsoft YaHei" pitchFamily="34" charset="-120"/>
               </a:rPr>
-              <a:t>基础模型提供通用表征，但不会自动完成下游 token 读取与异构知识注入。</a:t>
+              <a:t>基础模型解决表征来源；项目进一步研究时序解码与异构先验融合。</a:t>
             </a:r>
             <a:endParaRPr lang="en-US" sz="1600" dirty="0"/>
           </a:p>
@@ -20752,7 +20753,7 @@
                 <a:ea typeface="Microsoft YaHei" pitchFamily="34" charset="-122"/>
                 <a:cs typeface="Microsoft YaHei" pitchFamily="34" charset="-120"/>
               </a:rPr>
-              <a:t>Sources: [Galileo25] [PASTIS21] [DPT21]</a:t>
+              <a:t>Sources: [Galileo25] [PASTIS21] [SSL]</a:t>
             </a:r>
             <a:endParaRPr lang="en-US" sz="800" dirty="0"/>
           </a:p>

</xml_diff>